<commit_message>
Fresh-file replication, quiz retest, Windows setup
</commit_message>
<xml_diff>
--- a/docs/deck/MyTutor Demo version 3.3.pptx
+++ b/docs/deck/MyTutor Demo version 3.3.pptx
@@ -777,7 +777,7 @@
           <a:p>
             <a:r>
               <a:rPr lang="en-US" dirty="0"/>
-              <a:t>The build is a Python pipeline orchestrated by n8n on my laptop. I save a file into my course folder in OneDrive. n8n checks the folder every 15 minutes and runs run.py, which retrieves the new files, extracts their text, calls the Claude API once per source for notes, links and five quiz questions, files the notes into my Obsidian vault without overwriting my edits, logs the run, and rebuilds the offline practice page. Finished files are recorded, so nothing is paid for twice. Proof from the logs: through n8n, Days 2 to 6 and Day 10, 24 sources in all, became 192 notes for 2.68 US dollars with no failures. To be precise, the runs that processed files were ones I started from n8n; separately, the published 15-minute schedule ran unattended 100 times between 25 and 27 October with no failures, each time checking the folder and correctly finding nothing new. Constraints: API cost is capped by a spending limit and logged; course files go to an AI service, so I process only my own courses and follow UC guidance; scanned PDFs need OCR, which is not built yet; and if n8n is down, Windows Task Scheduler runs the same command.
+              <a:t>The build is a Python pipeline orchestrated by n8n on my laptop. I save a file into my course folder in OneDrive. n8n checks the folder every 15 minutes and runs run.py, which retrieves the new files, extracts their text, calls the Claude API once per source for notes, links and five quiz questions, files the notes into my Obsidian vault without overwriting my edits, logs the run, and rebuilds the offline practice page. Finished files are recorded, so nothing is paid for twice. Proof from the logs: through n8n, Days 2 to 6 and Day 10, 24 sources in all, became 192 notes for 2.68 US dollars with no failures. To be precise, the runs that processed files were ones I started from n8n; separately, the published 15-minute schedule ran unattended 100 times between 25 and 27 October with no failures, each time checking the folder and correctly finding nothing new. Constraints: API cost is capped by a spending limit and logged; course files go to an AI service, so I process only my own courses and follow UC guidance; scanned PDFs need OCR, which is not built yet; and if n8n is down, Windows Task Scheduler runs the same command. To check that someone else could set it up, I cloned version 3.3 from GitHub into a clean folder on Windows, installed the pinned versions in a fresh environment, and all 63 unit tests passed.
 Code and documentation: https://github.com/henrynawaung/mytutor</a:t>
             </a:r>
             <a:endParaRPr lang="en-US" dirty="0"/>
@@ -955,7 +955,7 @@
           <a:p>
             <a:r>
               <a:rPr lang="en-US" dirty="0"/>
-              <a:t>myTutor also builds a practice page: a fixed set of 20 questions per teaching day, drawn from the quiz notes, which works offline with no AI call while I practise. When I get an answer wrong, it shows the right answer, explains why, gives the key concept, and opens the source note in Obsidian in one click. This is the feature both classmates asked for. For the recall KPI, I took the Day 9 set from memory six days after the notes were made, well past the 48-hour mark, and scored 17 out of 20, 85 percent. I want to be careful about the claim: that is one test by one person, with no comparison yet against notes made by hand, so it shows the guardrail holding, not that myTutor improves learning. For context, my usual range on quizzes after studying my own manual notes is 17 to 19 out of 20, so this result sits within it. That is an informal impression, not a logged or like-for-like comparison, so it suggests recall did not drop, but it does not prove it. The next experiment is that comparison. I also had the question set rated by a separate AI review as a provisional check of quiz quality: 72 out of 100, strong on topic coverage and accuracy, weakest on distractors, the wrong options, at 5 out of 10; question by question it averaged 7.2 out of 10, ranging from 6 to 8, which means a student can sometimes reach the right answer by elimination without knowing the theory. The review also found 11 of the 20 correct answers were option B. So 17 out of 20 may overstate recall. I fixed one issue and retested it, answer-position balance only: the practice page now shuffles answer positions. On the real Day 9 set, an automated browser took the quiz 20 times with the old page and 200 times with the new one. Before, B was correct in 55 percent of questions every time; after, it was 24 percent, with A, C and D at about 25 percent each, and choosing the right answer still scored 20 out of 20 in every run. That is the pattern for the other fixes: the prompt now asks for plausible wrong options and a mix of recall, application and analytical questions, and I will re-rate the Day 10 set to test it, measuring whether wrong options are plausible, whether questions can be answered by elimination without knowing the subject, and whether they test application rather than recognition, using the 72 out of 100 review as the benchmark. Shuffling fixed the answer positions; it does not by itself make distractors more convincing.
+              <a:t>myTutor also builds a practice page: a fixed set of 20 questions per teaching day, drawn from the quiz notes, which works offline with no AI call while I practise. When I get an answer wrong, it shows the right answer, explains why, gives the key concept, and opens the source note in Obsidian in one click. This is the feature both classmates asked for. For the recall KPI, I took the Day 9 set from memory six days after the notes were made, well past the 48-hour mark, and scored 17 out of 20, 85 percent. I want to be careful about the claim: that is one test by one person, with no comparison yet against notes made by hand, so it shows the guardrail holding, not that myTutor improves learning. For context, my usual range on quizzes after studying my own manual notes is 17 to 19 out of 20, so this result sits within it. That is an informal impression, not a logged or like-for-like comparison, so it suggests recall did not drop, but it does not prove it. The next experiment is that comparison. I also had the question set rated by a separate AI review as a provisional check of quiz quality: 72 out of 100, strong on topic coverage and accuracy, weakest on distractors, the wrong options, at 5 out of 10; question by question it averaged 7.2 out of 10, ranging from 6 to 8, which means a student can sometimes reach the right answer by elimination without knowing the theory. The review also found 11 of the 20 correct answers were option B. So 17 out of 20 may overstate recall. I fixed one issue and retested it, answer-position balance only: the practice page now shuffles answer positions. On the real Day 9 set, an automated browser took the quiz 20 times with the old page and 200 times with the new one. Before, B was correct in 55 percent of questions every time; after, it was 24 percent, with A, C and D at about 25 percent each, and choosing the right answer still scored 20 out of 20 in every run. That is the pattern for the other fixes: the prompt now asks for plausible wrong options and a mix of recall, application and analytical questions, and I retested it on 1 November: the 20-question Day 11 set, made with the new prompt from four fresh files, was rated by the same kind of AI review. It scored 76 out of 100 against 72, strong on source grounding and scenarios, but distractors still need work: some wrong options are clearly weaker, correct answers tend to be longer, and one question gave a clue to another. So the prompt change helped a little but did not solve distractors, and the next fix is a separate quality-check step that rewrites weak options and checks option length and leakage before the quiz is saved. Shuffling fixed the answer positions; it does not by itself make distractors more convincing.
 Code and documentation: https://github.com/henrynawaung/mytutor</a:t>
             </a:r>
             <a:endParaRPr lang="en-US" dirty="0"/>
@@ -1133,7 +1133,7 @@
           <a:p>
             <a:r>
               <a:rPr lang="en-US" dirty="0"/>
-              <a:t>Each pair of bars is one file: the upper, lighter bar is the manual time; the lower, orange bar is myTutor's note generation plus my review, the per-file basis of the 73 percent figure; the end-to-end total adds 0.2 minutes of extraction and filing. Every file was faster. The gain is largest on long or dense files, 79 percent on the book sections, and smallest on the shortest file, a 350-word reading, at 58 percent, because review time grows with the number of notes, not the length of the file. The sensitivity check: if review took 30 seconds a note instead of 15, myTutor's full-run total would be 3.8 plus 17, 20.8 minutes, still 53 percent less, and myTutor stays faster unless review exceeds 1.2 minutes per note. The limits: five files, one tester, self-timed; I did the manual run first, so I knew the content when reviewing myTutor's notes, which may favour myTutor; file lengths vary widely; and quality was first checked for structure. I then checked accuracy on the ten sampled Day 9 notes: 32 statements compared with the extracted source text, with Claude's help. 31 were supported by the source; one note added an interpretation that the case does not state. I then re-checked seven of those rows myself against the original PDFs and slides, including the disputed one, and agreed with every result. One more limit: the sensitivity check tests a slower review mathematically; I have not yet repeated the timing experiment on fresh files, which is the next experiment. Because the accuracy check was AI-assisted, I then did a manual self-audit of a fresh sample, checking my own tool's output myself, so it is not an independent review. On Day 10, n8n had already drawn ten random notes before I checked anything. I audited the eight case and concept notes, leaving the two quiz notes to the separate quiz-quality test: 30 factual claims, each checked against the original article with a page and column reference. All 30 were supported, with no substantive errors. Two were close paraphrases, for example the source says innovation usually loses out where the note says the core wins. That is two samples, 18 notes across two days, by one reviewer checking his own tool, so it strengthens the result rather than proves it, and the sample happened to contain no reference notes.
+              <a:t>Each pair of bars is one file: the upper, lighter bar is the manual time; the lower, orange bar is myTutor's note generation plus my review, the per-file basis of the 73 percent figure; the end-to-end total adds 0.2 minutes of extraction and filing. Every file was faster. The gain is largest on long or dense files, 79 percent on the book sections, and smallest on the shortest file, a 350-word reading, at 58 percent, because review time grows with the number of notes, not the length of the file. The sensitivity check: if review took 30 seconds a note instead of 15, myTutor's full-run total would be 3.8 plus 17, 20.8 minutes, still 53 percent less, and myTutor stays faster unless review exceeds 1.2 minutes per note. The limits: five files, one tester, self-timed; I did the manual run first, so I knew the content when reviewing myTutor's notes, which may favour myTutor; file lengths vary widely; and quality was first checked for structure. I then checked accuracy on the ten sampled Day 9 notes: 32 statements compared with the extracted source text, with Claude's help. 31 were supported by the source; one note added an interpretation that the case does not state. I then re-checked seven of those rows myself against the original PDFs and slides, including the disputed one, and agreed with every result. Because the reviewer asked whether the saving holds on fresh material, I repeated the timing on 1 November with four files I had never opened. To remove the familiarity problem, each file was done one way only: two by hand with my baseline prompt and steps, two with myTutor, comparable in length, about 4,000 words a side. By hand took 15.2 minutes for 4,138 words, 3.68 minutes per thousand words. myTutor took 2.0 minutes of logged run plus 2.4 minutes of my timed review of all 17 notes, 4.4 minutes for 3,938 words, 1.11 per thousand: 70 percent less, against 72 percent on Day 9. Even at a 15-second review per note it is 57 percent less. 12 of 14 manual notes and all 17 myTutor notes passed the five checks. The limit is that the files differ between methods, so file difficulty is not held constant; it is one tester on one afternoon. Because the accuracy check was AI-assisted, I then did a manual self-audit of a fresh sample, checking my own tool's output myself, so it is not an independent review. On Day 10, n8n had already drawn ten random notes before I checked anything. I audited the eight case and concept notes, leaving the two quiz notes to the separate quiz-quality test: 30 factual claims, each checked against the original article with a page and column reference. All 30 were supported, with no substantive errors. Two were close paraphrases, for example the source says innovation usually loses out where the note says the core wins. That is two samples, 18 notes across two days, by one reviewer checking his own tool, so it strengthens the result rather than proves it, and the sample happened to contain no reference notes.
 Code and documentation: https://github.com/henrynawaung/mytutor</a:t>
             </a:r>
             <a:endParaRPr lang="en-US" dirty="0"/>
@@ -1222,7 +1222,7 @@
           <a:p>
             <a:r>
               <a:rPr lang="en-US" dirty="0"/>
-              <a:t>What worked: on five files, 72 percent less time, 62 percent more links to existing notes, every note passing the structural checks, for 48 cents, and in live use since 25 October it has turned 24 sources from six teaching days into 192 notes, with every one of 100 audited notes in the right folder with complete properties. Each failure has a cause and a testable fix. The Kowhai case got no case note because the prompt writes case notes only for real organisations, so I will add a rule for teaching cases and retest on five cases. A whole book as one file gave only three to six concepts because one call compresses a long text, so I will split readings by section and compare concepts per section. An accuracy check of the ten sampled Day 9 notes found 31 of 32 statements supported by the source; one added an interpretation the case does not state, because the prompt invites a 'why it matters' comment, so interpretation will be marked as analysis. Because that check was AI-assisted, I did a manual self-audit of a Day 10 sample, against the original articles with page references: 30 of 30 claims across eight notes were supported. Recall held up, 17 out of 20 from memory six days later, but with nothing to compare against, so I will run the same test on notes made by hand, and add new questions on the same concepts in different scenarios, to test transfer rather than recognition. 85 percent on this quiz is not 85 percent mastery. A provisional AI review rated the quiz 72 out of 100, weakest on distractors, so I will prompt for more plausible wrong options and re-rate the Day 10 set. And the live audit of 100 sampled notes found only 52 linking to an older note, likely because quiz notes and new topics have few older notes to link to, so I will measure concept notes only, prompt for related notes, and re-audit. Risks: course files go to an AI service, so licences and UC guidance apply; there is no OCR yet; cost grows with volume; and the evidence is from one tester. Adoption: next, classmates in my cohort. Longer term the same pattern could become a company brain for an SME or a corporate, where access control and governance would come before the AI.
+              <a:t>What worked: on five files, 72 percent less time, replicated at 70 percent on four unseen files, 62 percent more links to existing notes, every note passing the structural checks, for 48 cents, and in live use since 25 October it has turned 24 sources from six teaching days into 192 notes, with every one of 100 audited notes in the right folder with complete properties. Each failure has a cause and a testable fix. The Kowhai case got no case note because the prompt writes case notes only for real organisations, so I will add a rule for teaching cases and retest on five cases. A whole book as one file gave only three to six concepts because one call compresses a long text, so I will split readings by section and compare concepts per section. An accuracy check of the ten sampled Day 9 notes found 31 of 32 statements supported by the source; one added an interpretation the case does not state, because the prompt invites a 'why it matters' comment, so interpretation will be marked as analysis. Because that check was AI-assisted, I did a manual self-audit of a Day 10 sample, against the original articles with page references: 30 of 30 claims across eight notes were supported. Recall held up, 17 out of 20 from memory six days later, but with nothing to compare against, so I will run the same test on notes made by hand, and add new questions on the same concepts in different scenarios, to test transfer rather than recognition. 85 percent on this quiz is not 85 percent mastery. A provisional AI review rated the quiz 72 out of 100, weakest on distractors. I changed the prompt and retested on the fresh Day 11 set: 76 out of 100, a small gain, with distractors still the weakest part, so the prompt alone was not enough and the next change is an automatic quality check on each quiz. And the live audit of 100 sampled notes found only 52 linking to an older note, likely because quiz notes and new topics have few older notes to link to, so I will measure concept notes only, prompt for related notes, and re-audit. Risks: course files go to an AI service, so licences and UC guidance apply; there is no OCR yet; cost grows with volume; and the evidence is from one tester. Adoption: next, classmates in my cohort. Longer term the same pattern could become a company brain for an SME or a corporate, where access control and governance would come before the AI.
 Code and documentation: https://github.com/henrynawaung/mytutor</a:t>
             </a:r>
             <a:endParaRPr lang="en-US" dirty="0"/>
@@ -2224,7 +2224,7 @@
       </p:grpSpPr>
       <p:pic>
         <p:nvPicPr>
-          <p:cNvPr id="2" name="Image 0" descr="Slide 8: Every file faster, even with a slower review">    </p:cNvPr>
+          <p:cNvPr id="2" name="Image 0" descr="Slide 8: Every file faster, and again on four unseen files">    </p:cNvPr>
           <p:cNvPicPr>
             <a:picLocks noChangeAspect="1"/>
           </p:cNvPicPr>

</xml_diff>

<commit_message>
Independent check: 2 classmates agree on 10 of 10
</commit_message>
<xml_diff>
--- a/docs/deck/MyTutor Demo version 3.3.pptx
+++ b/docs/deck/MyTutor Demo version 3.3.pptx
@@ -1133,7 +1133,7 @@
           <a:p>
             <a:r>
               <a:rPr lang="en-US" dirty="0"/>
-              <a:t>Each pair of bars is one file: the upper, lighter bar is the manual time; the lower, orange bar is myTutor's note generation plus my review, the per-file basis of the 73 percent figure; the end-to-end total adds 0.2 minutes of extraction and filing. Every file was faster. The gain is largest on long or dense files, 79 percent on the book sections, and smallest on the shortest file, a 350-word reading, at 58 percent, because review time grows with the number of notes, not the length of the file. The sensitivity check: if review took 30 seconds a note instead of 15, myTutor's full-run total would be 3.8 plus 17, 20.8 minutes, still 53 percent less, and myTutor stays faster unless review exceeds 1.2 minutes per note. The limits: five files, one tester, self-timed; I did the manual run first, so I knew the content when reviewing myTutor's notes, which may favour myTutor; file lengths vary widely; and quality was first checked for structure. I then checked accuracy on the ten sampled Day 9 notes: 32 statements compared with the extracted source text, with Claude's help. 31 were supported by the source; one note added an interpretation that the case does not state. I then re-checked seven of those rows myself against the original PDFs and slides, including the disputed one, and agreed with every result. Because the reviewer asked whether the saving holds on fresh material, I repeated the timing on 1 November with four files I had never opened. To remove the familiarity problem, each file was done one way only: two by hand with my baseline prompt and steps, two with myTutor, comparable in length, about 4,000 words a side. By hand took 15.2 minutes for 4,138 words, 3.68 minutes per thousand words. myTutor took 2.0 minutes of logged run plus 2.4 minutes of my timed review of all 17 notes, 4.4 minutes for 3,938 words, 1.11 per thousand: 70 percent less, against 72 percent on Day 9. Even at a 15-second review per note it is 57 percent less. 12 of 14 manual notes and all 17 myTutor notes passed the five checks. The limit is that the files differ between methods, so file difficulty is not held constant; it is one tester on one afternoon. Because the accuracy check was AI-assisted, I then did a manual self-audit of a fresh sample, checking my own tool's output myself, so it is not an independent review. On Day 10, n8n had already drawn ten random notes before I checked anything. I audited the eight case and concept notes, leaving the two quiz notes to the separate quiz-quality test: 30 factual claims, each checked against the original article with a page and column reference. All 30 were supported, with no substantive errors. Two were close paraphrases, for example the source says innovation usually loses out where the note says the core wins. That is two samples, 18 notes across two days, by one reviewer checking his own tool, so it strengthens the result rather than proves it, and the sample happened to contain no reference notes.
+              <a:t>Each pair of bars is one file: the upper, lighter bar is the manual time; the lower, orange bar is myTutor's note generation plus my review, the per-file basis of the 73 percent figure; the end-to-end total adds 0.2 minutes of extraction and filing. Every file was faster. The gain is largest on long or dense files, 79 percent on the book sections, and smallest on the shortest file, a 350-word reading, at 58 percent, because review time grows with the number of notes, not the length of the file. The sensitivity check: if review took 30 seconds a note instead of 15, myTutor's full-run total would be 3.8 plus 17, 20.8 minutes, still 53 percent less, and myTutor stays faster unless review exceeds 1.2 minutes per note. The limits: five files, one tester, self-timed; I did the manual run first, so I knew the content when reviewing myTutor's notes, which may favour myTutor; file lengths vary widely; and quality was first checked for structure. I then checked accuracy on the ten sampled Day 9 notes: 32 statements compared with the extracted source text, with Claude's help. 31 were supported by the source; one note added an interpretation that the case does not state. I then re-checked seven of those rows myself against the original PDFs and slides, including the disputed one, and agreed with every result. Because the reviewer asked whether the saving holds on fresh material, I repeated the timing on 1 November with four files I had never opened. To remove the familiarity problem, each file was done one way only: two by hand with my baseline prompt and steps, two with myTutor, comparable in length, about 4,000 words a side. By hand took 15.2 minutes for 4,138 words, 3.68 minutes per thousand words. myTutor took 2.0 minutes of logged run plus 2.4 minutes of my timed review of all 17 notes, 4.4 minutes for 3,938 words, 1.11 per thousand: 70 percent less, against 72 percent on Day 9. Even at a 15-second review per note it is 57 percent less. 12 of 14 manual notes and all 17 myTutor notes passed the five checks. The limit is that the files differ between methods, so file difficulty is not held constant; it is one tester on one afternoon. Because the accuracy check was AI-assisted, I then did a manual self-audit of a fresh sample, checking my own tool's output myself, so it is not an independent review. On Day 10, n8n had already drawn ten random notes before I checked anything. I audited the eight case and concept notes, leaving the two quiz notes to the separate quiz-quality test: 30 factual claims, each checked against the original article with a page and column reference. All 30 were supported, with no substantive errors. Two were close paraphrases, for example the source says innovation usually loses out where the note says the core wins. That is two samples, 18 notes across two days, by one reviewer checking his own tool. To make it partly independent, two classmates, Shawn and Faiiz, each checked five of the 30 claims, drawn at random, against the original readings without seeing my ratings, and both rated all five supported, so 10 of 10 agree. That strengthens the result rather than proves it, and the sample happened to contain no reference notes.
 Code and documentation: https://github.com/henrynawaung/mytutor</a:t>
             </a:r>
             <a:endParaRPr lang="en-US" dirty="0"/>
@@ -1222,7 +1222,7 @@
           <a:p>
             <a:r>
               <a:rPr lang="en-US" dirty="0"/>
-              <a:t>What worked: on five files, 72 percent less time, replicated at 70 percent on four unseen files, 62 percent more links to existing notes, every note passing the structural checks, for 48 cents, and in live use since 25 October it has turned 24 sources from six teaching days into 192 notes, with every one of 100 audited notes in the right folder with complete properties. Each failure has a cause and a testable fix. The Kowhai case got no case note because the prompt writes case notes only for real organisations, so I will add a rule for teaching cases and retest on five cases. A whole book as one file gave only three to six concepts because one call compresses a long text, so I will split readings by section and compare concepts per section. An accuracy check of the ten sampled Day 9 notes found 31 of 32 statements supported by the source; one added an interpretation the case does not state, because the prompt invites a 'why it matters' comment, so interpretation will be marked as analysis. Because that check was AI-assisted, I did a manual self-audit of a Day 10 sample, against the original articles with page references: 30 of 30 claims across eight notes were supported. Recall held up, 17 out of 20 from memory six days later, but with nothing to compare against, so I will run the same test on notes made by hand, and add new questions on the same concepts in different scenarios, to test transfer rather than recognition. 85 percent on this quiz is not 85 percent mastery. A provisional AI review rated the quiz 72 out of 100, weakest on distractors. I changed the prompt and retested on the fresh Day 11 set: 76 out of 100, a small gain, with distractors still the weakest part, so the prompt alone was not enough and the next change is an automatic quality check on each quiz. And the live audit of 100 sampled notes found only 52 linking to an older note, likely because quiz notes and new topics have few older notes to link to, so I will measure concept notes only, prompt for related notes, and re-audit. Risks: course files go to an AI service, so licences and UC guidance apply; there is no OCR yet; cost grows with volume; and the evidence is from one tester. Adoption: next, classmates in my cohort. Longer term the same pattern could become a company brain for an SME or a corporate, where access control and governance would come before the AI.
+              <a:t>What worked: on five files, 72 percent less time, replicated at 70 percent on four unseen files, 62 percent more links to existing notes, every note passing the structural checks, for 48 cents, and in live use since 25 October it has turned 24 sources from six teaching days into 192 notes, with every one of 100 audited notes in the right folder with complete properties. Each failure has a cause and a testable fix. The Kowhai case got no case note because the prompt writes case notes only for real organisations, so I will add a rule for teaching cases and retest on five cases. A whole book as one file gave only three to six concepts because one call compresses a long text, so I will split readings by section and compare concepts per section. An accuracy check of the ten sampled Day 9 notes found 31 of 32 statements supported by the source; one added an interpretation the case does not state, because the prompt invites a 'why it matters' comment, so interpretation will be marked as analysis. Because that check was AI-assisted, I did a manual self-audit of a Day 10 sample, against the original articles with page references: 30 of 30 claims across eight notes were supported, and two classmates who blind-checked ten of them agreed on all ten. Recall held up, 17 out of 20 from memory six days later, but with nothing to compare against, so I will run the same test on notes made by hand, and add new questions on the same concepts in different scenarios, to test transfer rather than recognition. 85 percent on this quiz is not 85 percent mastery. A provisional AI review rated the quiz 72 out of 100, weakest on distractors. I changed the prompt and retested on the fresh Day 11 set: 76 out of 100, a small gain, with distractors still the weakest part, so the prompt alone was not enough and the next change is an automatic quality check on each quiz. And the live audit of 100 sampled notes found only 52 linking to an older note, likely because quiz notes and new topics have few older notes to link to, so I will measure concept notes only, prompt for related notes, and re-audit. Risks: course files go to an AI service, so licences and UC guidance apply; there is no OCR yet; cost grows with volume; and the evidence is from one tester. Adoption: next, classmates in my cohort. Longer term the same pattern could become a company brain for an SME or a corporate, where access control and governance would come before the AI.
 Code and documentation: https://github.com/henrynawaung/mytutor</a:t>
             </a:r>
             <a:endParaRPr lang="en-US" dirty="0"/>

</xml_diff>